<commit_message>
docs: rebuild PPT slides with official EFREI white logo footer
</commit_message>
<xml_diff>
--- a/docs/Soutenance_Urban_Data_Explorer.pptx
+++ b/docs/Soutenance_Urban_Data_Explorer.pptx
@@ -3387,7 +3387,7 @@
       </p:sp>
       <p:pic>
         <p:nvPicPr>
-          <p:cNvPr id="9" name="Picture 8" descr="efrei-logo.png"/>
+          <p:cNvPr id="9" name="Picture 8" descr="efrei-logo-white.png"/>
           <p:cNvPicPr>
             <a:picLocks noChangeAspect="1"/>
           </p:cNvPicPr>
@@ -3402,7 +3402,7 @@
         <p:spPr>
           <a:xfrm>
             <a:off x="9814255" y="502920"/>
-            <a:ext cx="2552842" cy="914400"/>
+            <a:ext cx="1828191" cy="914400"/>
           </a:xfrm>
           <a:prstGeom prst="rect">
             <a:avLst/>
@@ -4488,7 +4488,7 @@
       </p:sp>
       <p:pic>
         <p:nvPicPr>
-          <p:cNvPr id="28" name="Picture 27" descr="efrei-logo.png"/>
+          <p:cNvPr id="28" name="Picture 27" descr="efrei-logo-white.png"/>
           <p:cNvPicPr>
             <a:picLocks noChangeAspect="1"/>
           </p:cNvPicPr>
@@ -4503,7 +4503,7 @@
         <p:spPr>
           <a:xfrm>
             <a:off x="11277295" y="6583680"/>
-            <a:ext cx="638210" cy="228600"/>
+            <a:ext cx="457048" cy="228600"/>
           </a:xfrm>
           <a:prstGeom prst="rect">
             <a:avLst/>
@@ -4859,7 +4859,7 @@
       </p:sp>
       <p:pic>
         <p:nvPicPr>
-          <p:cNvPr id="10" name="Picture 9" descr="efrei-logo.png"/>
+          <p:cNvPr id="10" name="Picture 9" descr="efrei-logo-white.png"/>
           <p:cNvPicPr>
             <a:picLocks noChangeAspect="1"/>
           </p:cNvPicPr>
@@ -4874,7 +4874,7 @@
         <p:spPr>
           <a:xfrm>
             <a:off x="11277295" y="6583680"/>
-            <a:ext cx="638210" cy="228600"/>
+            <a:ext cx="457048" cy="228600"/>
           </a:xfrm>
           <a:prstGeom prst="rect">
             <a:avLst/>
@@ -5641,7 +5641,7 @@
       </p:sp>
       <p:pic>
         <p:nvPicPr>
-          <p:cNvPr id="20" name="Picture 19" descr="efrei-logo.png"/>
+          <p:cNvPr id="20" name="Picture 19" descr="efrei-logo-white.png"/>
           <p:cNvPicPr>
             <a:picLocks noChangeAspect="1"/>
           </p:cNvPicPr>
@@ -5656,7 +5656,7 @@
         <p:spPr>
           <a:xfrm>
             <a:off x="11277295" y="6583680"/>
-            <a:ext cx="638210" cy="228600"/>
+            <a:ext cx="457048" cy="228600"/>
           </a:xfrm>
           <a:prstGeom prst="rect">
             <a:avLst/>
@@ -6340,7 +6340,7 @@
       </p:sp>
       <p:pic>
         <p:nvPicPr>
-          <p:cNvPr id="18" name="Picture 17" descr="efrei-logo.png"/>
+          <p:cNvPr id="18" name="Picture 17" descr="efrei-logo-white.png"/>
           <p:cNvPicPr>
             <a:picLocks noChangeAspect="1"/>
           </p:cNvPicPr>
@@ -6355,7 +6355,7 @@
         <p:spPr>
           <a:xfrm>
             <a:off x="11277295" y="6583680"/>
-            <a:ext cx="638210" cy="228600"/>
+            <a:ext cx="457048" cy="228600"/>
           </a:xfrm>
           <a:prstGeom prst="rect">
             <a:avLst/>
@@ -7317,7 +7317,7 @@
       </p:sp>
       <p:pic>
         <p:nvPicPr>
-          <p:cNvPr id="25" name="Picture 24" descr="efrei-logo.png"/>
+          <p:cNvPr id="25" name="Picture 24" descr="efrei-logo-white.png"/>
           <p:cNvPicPr>
             <a:picLocks noChangeAspect="1"/>
           </p:cNvPicPr>
@@ -7332,7 +7332,7 @@
         <p:spPr>
           <a:xfrm>
             <a:off x="11277295" y="6583680"/>
-            <a:ext cx="638210" cy="228600"/>
+            <a:ext cx="457048" cy="228600"/>
           </a:xfrm>
           <a:prstGeom prst="rect">
             <a:avLst/>
@@ -8418,7 +8418,7 @@
       </p:sp>
       <p:pic>
         <p:nvPicPr>
-          <p:cNvPr id="28" name="Picture 27" descr="efrei-logo.png"/>
+          <p:cNvPr id="28" name="Picture 27" descr="efrei-logo-white.png"/>
           <p:cNvPicPr>
             <a:picLocks noChangeAspect="1"/>
           </p:cNvPicPr>
@@ -8433,7 +8433,7 @@
         <p:spPr>
           <a:xfrm>
             <a:off x="11277295" y="6583680"/>
-            <a:ext cx="638210" cy="228600"/>
+            <a:ext cx="457048" cy="228600"/>
           </a:xfrm>
           <a:prstGeom prst="rect">
             <a:avLst/>
@@ -11954,7 +11954,7 @@
       </p:sp>
       <p:pic>
         <p:nvPicPr>
-          <p:cNvPr id="90" name="Picture 89" descr="efrei-logo.png"/>
+          <p:cNvPr id="90" name="Picture 89" descr="efrei-logo-white.png"/>
           <p:cNvPicPr>
             <a:picLocks noChangeAspect="1"/>
           </p:cNvPicPr>
@@ -11969,7 +11969,7 @@
         <p:spPr>
           <a:xfrm>
             <a:off x="11277295" y="6583680"/>
-            <a:ext cx="638210" cy="228600"/>
+            <a:ext cx="457048" cy="228600"/>
           </a:xfrm>
           <a:prstGeom prst="rect">
             <a:avLst/>
@@ -13392,7 +13392,7 @@
       </p:sp>
       <p:pic>
         <p:nvPicPr>
-          <p:cNvPr id="36" name="Picture 35" descr="efrei-logo.png"/>
+          <p:cNvPr id="36" name="Picture 35" descr="efrei-logo-white.png"/>
           <p:cNvPicPr>
             <a:picLocks noChangeAspect="1"/>
           </p:cNvPicPr>
@@ -13407,7 +13407,7 @@
         <p:spPr>
           <a:xfrm>
             <a:off x="11277295" y="6583680"/>
-            <a:ext cx="638210" cy="228600"/>
+            <a:ext cx="457048" cy="228600"/>
           </a:xfrm>
           <a:prstGeom prst="rect">
             <a:avLst/>
@@ -14788,7 +14788,7 @@
       </p:sp>
       <p:pic>
         <p:nvPicPr>
-          <p:cNvPr id="35" name="Picture 34" descr="efrei-logo.png"/>
+          <p:cNvPr id="35" name="Picture 34" descr="efrei-logo-white.png"/>
           <p:cNvPicPr>
             <a:picLocks noChangeAspect="1"/>
           </p:cNvPicPr>
@@ -14803,7 +14803,7 @@
         <p:spPr>
           <a:xfrm>
             <a:off x="11277295" y="6583680"/>
-            <a:ext cx="638210" cy="228600"/>
+            <a:ext cx="457048" cy="228600"/>
           </a:xfrm>
           <a:prstGeom prst="rect">
             <a:avLst/>
@@ -16215,7 +16215,7 @@
       </p:sp>
       <p:pic>
         <p:nvPicPr>
-          <p:cNvPr id="36" name="Picture 35" descr="efrei-logo.png"/>
+          <p:cNvPr id="36" name="Picture 35" descr="efrei-logo-white.png"/>
           <p:cNvPicPr>
             <a:picLocks noChangeAspect="1"/>
           </p:cNvPicPr>
@@ -16230,7 +16230,7 @@
         <p:spPr>
           <a:xfrm>
             <a:off x="11277295" y="6583680"/>
-            <a:ext cx="638210" cy="228600"/>
+            <a:ext cx="457048" cy="228600"/>
           </a:xfrm>
           <a:prstGeom prst="rect">
             <a:avLst/>
@@ -17153,7 +17153,7 @@
       </p:sp>
       <p:pic>
         <p:nvPicPr>
-          <p:cNvPr id="24" name="Picture 23" descr="efrei-logo.png"/>
+          <p:cNvPr id="24" name="Picture 23" descr="efrei-logo-white.png"/>
           <p:cNvPicPr>
             <a:picLocks noChangeAspect="1"/>
           </p:cNvPicPr>
@@ -17168,7 +17168,7 @@
         <p:spPr>
           <a:xfrm>
             <a:off x="11277295" y="6583680"/>
-            <a:ext cx="638210" cy="228600"/>
+            <a:ext cx="457048" cy="228600"/>
           </a:xfrm>
           <a:prstGeom prst="rect">
             <a:avLst/>

</xml_diff>